<commit_message>
Adiciona video executivo e documenta no README
Video de ate 5 min (problema de negocio, arquitetura, valor para
analises educacionais, potencial de IA) na pasta reports/presentation/,
junto com a versao atualizada da apresentacao de apoio (pptx).
</commit_message>
<xml_diff>
--- a/reports/presentation/Alfabetizacao_Apresentacao.pptx
+++ b/reports/presentation/Alfabetizacao_Apresentacao.pptx
@@ -310,7 +310,7 @@
           <a:p>
             <a:fld id="{5BCAD085-E8A6-8845-BD4E-CB4CCA059FC4}" type="datetimeFigureOut">
               <a:rPr lang="en-US" smtClean="0"/>
-              <a:t>8/23/2026</a:t>
+              <a:t>8/29/2026</a:t>
             </a:fld>
             <a:endParaRPr lang="en-US"/>
           </a:p>
@@ -478,7 +478,7 @@
           <a:p>
             <a:fld id="{5BCAD085-E8A6-8845-BD4E-CB4CCA059FC4}" type="datetimeFigureOut">
               <a:rPr lang="en-US" smtClean="0"/>
-              <a:t>8/23/2026</a:t>
+              <a:t>8/29/2026</a:t>
             </a:fld>
             <a:endParaRPr lang="en-US"/>
           </a:p>
@@ -656,7 +656,7 @@
           <a:p>
             <a:fld id="{5BCAD085-E8A6-8845-BD4E-CB4CCA059FC4}" type="datetimeFigureOut">
               <a:rPr lang="en-US" smtClean="0"/>
-              <a:t>8/23/2026</a:t>
+              <a:t>8/29/2026</a:t>
             </a:fld>
             <a:endParaRPr lang="en-US"/>
           </a:p>
@@ -824,7 +824,7 @@
           <a:p>
             <a:fld id="{5BCAD085-E8A6-8845-BD4E-CB4CCA059FC4}" type="datetimeFigureOut">
               <a:rPr lang="en-US" smtClean="0"/>
-              <a:t>8/23/2026</a:t>
+              <a:t>8/29/2026</a:t>
             </a:fld>
             <a:endParaRPr lang="en-US"/>
           </a:p>
@@ -1069,7 +1069,7 @@
           <a:p>
             <a:fld id="{5BCAD085-E8A6-8845-BD4E-CB4CCA059FC4}" type="datetimeFigureOut">
               <a:rPr lang="en-US" smtClean="0"/>
-              <a:t>8/23/2026</a:t>
+              <a:t>8/29/2026</a:t>
             </a:fld>
             <a:endParaRPr lang="en-US"/>
           </a:p>
@@ -1354,7 +1354,7 @@
           <a:p>
             <a:fld id="{5BCAD085-E8A6-8845-BD4E-CB4CCA059FC4}" type="datetimeFigureOut">
               <a:rPr lang="en-US" smtClean="0"/>
-              <a:t>8/23/2026</a:t>
+              <a:t>8/29/2026</a:t>
             </a:fld>
             <a:endParaRPr lang="en-US"/>
           </a:p>
@@ -1773,7 +1773,7 @@
           <a:p>
             <a:fld id="{5BCAD085-E8A6-8845-BD4E-CB4CCA059FC4}" type="datetimeFigureOut">
               <a:rPr lang="en-US" smtClean="0"/>
-              <a:t>8/23/2026</a:t>
+              <a:t>8/29/2026</a:t>
             </a:fld>
             <a:endParaRPr lang="en-US"/>
           </a:p>
@@ -1890,7 +1890,7 @@
           <a:p>
             <a:fld id="{5BCAD085-E8A6-8845-BD4E-CB4CCA059FC4}" type="datetimeFigureOut">
               <a:rPr lang="en-US" smtClean="0"/>
-              <a:t>8/23/2026</a:t>
+              <a:t>8/29/2026</a:t>
             </a:fld>
             <a:endParaRPr lang="en-US"/>
           </a:p>
@@ -1985,7 +1985,7 @@
           <a:p>
             <a:fld id="{5BCAD085-E8A6-8845-BD4E-CB4CCA059FC4}" type="datetimeFigureOut">
               <a:rPr lang="en-US" smtClean="0"/>
-              <a:t>8/23/2026</a:t>
+              <a:t>8/29/2026</a:t>
             </a:fld>
             <a:endParaRPr lang="en-US"/>
           </a:p>
@@ -2260,7 +2260,7 @@
           <a:p>
             <a:fld id="{5BCAD085-E8A6-8845-BD4E-CB4CCA059FC4}" type="datetimeFigureOut">
               <a:rPr lang="en-US" smtClean="0"/>
-              <a:t>8/23/2026</a:t>
+              <a:t>8/29/2026</a:t>
             </a:fld>
             <a:endParaRPr lang="en-US"/>
           </a:p>
@@ -2512,7 +2512,7 @@
           <a:p>
             <a:fld id="{5BCAD085-E8A6-8845-BD4E-CB4CCA059FC4}" type="datetimeFigureOut">
               <a:rPr lang="en-US" smtClean="0"/>
-              <a:t>8/23/2026</a:t>
+              <a:t>8/29/2026</a:t>
             </a:fld>
             <a:endParaRPr lang="en-US"/>
           </a:p>
@@ -2723,7 +2723,7 @@
           <a:p>
             <a:fld id="{5BCAD085-E8A6-8845-BD4E-CB4CCA059FC4}" type="datetimeFigureOut">
               <a:rPr lang="en-US" smtClean="0"/>
-              <a:t>8/23/2026</a:t>
+              <a:t>8/29/2026</a:t>
             </a:fld>
             <a:endParaRPr lang="en-US"/>
           </a:p>
@@ -3434,6 +3434,14 @@
   <p:clrMapOvr>
     <a:masterClrMapping/>
   </p:clrMapOvr>
+  <mc:AlternateContent xmlns:mc="http://schemas.openxmlformats.org/markup-compatibility/2006" xmlns:p14="http://schemas.microsoft.com/office/powerpoint/2010/main">
+    <mc:Choice Requires="p14">
+      <p:transition spd="slow" p14:dur="2000" advTm="9061"/>
+    </mc:Choice>
+    <mc:Fallback xmlns="">
+      <p:transition spd="slow" advTm="9061"/>
+    </mc:Fallback>
+  </mc:AlternateContent>
 </p:sld>
 </file>
 
@@ -3495,7 +3503,7 @@
           <a:lstStyle/>
           <a:p>
             <a:pPr algn="ctr"/>
-            <a:endParaRPr/>
+            <a:endParaRPr lang="pt-BR"/>
           </a:p>
         </p:txBody>
       </p:sp>
@@ -3703,7 +3711,7 @@
         <p:spPr>
           <a:xfrm>
             <a:off x="365760" y="1920240"/>
-            <a:ext cx="11338560" cy="1938992"/>
+            <a:ext cx="11338560" cy="2169825"/>
           </a:xfrm>
           <a:prstGeom prst="rect">
             <a:avLst/>
@@ -3740,6 +3748,15 @@
               <a:t>O </a:t>
             </a:r>
             <a:r>
+              <a:rPr lang="pt-BR" sz="1500" dirty="0">
+                <a:solidFill>
+                  <a:srgbClr val="444444"/>
+                </a:solidFill>
+                <a:latin typeface="Calibri"/>
+              </a:rPr>
+              <a:t>CNCA (</a:t>
+            </a:r>
+            <a:r>
               <a:rPr sz="1500" dirty="0" err="1">
                 <a:solidFill>
                   <a:srgbClr val="444444"/>
@@ -3785,6 +3802,15 @@
               <a:t>Alfabetizada</a:t>
             </a:r>
             <a:r>
+              <a:rPr lang="pt-BR" sz="1500" dirty="0">
+                <a:solidFill>
+                  <a:srgbClr val="444444"/>
+                </a:solidFill>
+                <a:latin typeface="Calibri"/>
+              </a:rPr>
+              <a:t>)</a:t>
+            </a:r>
+            <a:r>
               <a:rPr sz="1500" dirty="0">
                 <a:solidFill>
                   <a:srgbClr val="444444"/>
@@ -3863,7 +3889,7 @@
                 </a:solidFill>
                 <a:latin typeface="Calibri"/>
               </a:rPr>
-              <a:t> para </a:t>
+              <a:t> para que </a:t>
             </a:r>
             <a:r>
               <a:rPr sz="1500" dirty="0" err="1">
@@ -3872,7 +3898,7 @@
                 </a:solidFill>
                 <a:latin typeface="Calibri"/>
               </a:rPr>
-              <a:t>que</a:t>
+              <a:t>toda</a:t>
             </a:r>
             <a:r>
               <a:rPr sz="1500" dirty="0">
@@ -3890,7 +3916,7 @@
                 </a:solidFill>
                 <a:latin typeface="Calibri"/>
               </a:rPr>
-              <a:t>toda</a:t>
+              <a:t>criança</a:t>
             </a:r>
             <a:r>
               <a:rPr sz="1500" dirty="0">
@@ -3908,7 +3934,7 @@
                 </a:solidFill>
                 <a:latin typeface="Calibri"/>
               </a:rPr>
-              <a:t>criança</a:t>
+              <a:t>esteja</a:t>
             </a:r>
             <a:r>
               <a:rPr sz="1500" dirty="0">
@@ -3926,7 +3952,7 @@
                 </a:solidFill>
                 <a:latin typeface="Calibri"/>
               </a:rPr>
-              <a:t>esteja</a:t>
+              <a:t>alfabetizada</a:t>
             </a:r>
             <a:r>
               <a:rPr sz="1500" dirty="0">
@@ -3944,7 +3970,7 @@
                 </a:solidFill>
                 <a:latin typeface="Calibri"/>
               </a:rPr>
-              <a:t>alfabetizada</a:t>
+              <a:t>até</a:t>
             </a:r>
             <a:r>
               <a:rPr sz="1500" dirty="0">
@@ -3953,7 +3979,7 @@
                 </a:solidFill>
                 <a:latin typeface="Calibri"/>
               </a:rPr>
-              <a:t> </a:t>
+              <a:t> o final do 2º </a:t>
             </a:r>
             <a:r>
               <a:rPr sz="1500" dirty="0" err="1">
@@ -3962,7 +3988,7 @@
                 </a:solidFill>
                 <a:latin typeface="Calibri"/>
               </a:rPr>
-              <a:t>até</a:t>
+              <a:t>ano</a:t>
             </a:r>
             <a:r>
               <a:rPr sz="1500" dirty="0">
@@ -3971,7 +3997,7 @@
                 </a:solidFill>
                 <a:latin typeface="Calibri"/>
               </a:rPr>
-              <a:t> o final do 2º </a:t>
+              <a:t> do </a:t>
             </a:r>
             <a:r>
               <a:rPr sz="1500" dirty="0" err="1">
@@ -3980,7 +4006,7 @@
                 </a:solidFill>
                 <a:latin typeface="Calibri"/>
               </a:rPr>
-              <a:t>ano</a:t>
+              <a:t>ensino</a:t>
             </a:r>
             <a:r>
               <a:rPr sz="1500" dirty="0">
@@ -3989,26 +4015,14 @@
                 </a:solidFill>
                 <a:latin typeface="Calibri"/>
               </a:rPr>
-              <a:t> do </a:t>
-            </a:r>
-            <a:r>
-              <a:rPr sz="1500" dirty="0" err="1">
-                <a:solidFill>
-                  <a:srgbClr val="444444"/>
-                </a:solidFill>
-                <a:latin typeface="Calibri"/>
-              </a:rPr>
-              <a:t>ensino</a:t>
-            </a:r>
-            <a:r>
-              <a:rPr sz="1500" dirty="0">
-                <a:solidFill>
-                  <a:srgbClr val="444444"/>
-                </a:solidFill>
-                <a:latin typeface="Calibri"/>
-              </a:rPr>
               <a:t> fundamental — meta: 2030.</a:t>
             </a:r>
+            <a:endParaRPr lang="pt-BR" sz="1500" dirty="0">
+              <a:solidFill>
+                <a:srgbClr val="444444"/>
+              </a:solidFill>
+              <a:latin typeface="Calibri"/>
+            </a:endParaRPr>
           </a:p>
           <a:p>
             <a:pPr>
@@ -4017,7 +4031,7 @@
               </a:spcAft>
             </a:pPr>
             <a:r>
-              <a:rPr sz="1500" b="1" dirty="0">
+              <a:rPr lang="pt-BR" sz="1500" b="1" dirty="0">
                 <a:solidFill>
                   <a:srgbClr val="2E86C1"/>
                 </a:solidFill>
@@ -4026,212 +4040,20 @@
               <a:t>▶  </a:t>
             </a:r>
             <a:r>
-              <a:rPr sz="1500" dirty="0">
-                <a:solidFill>
-                  <a:srgbClr val="444444"/>
-                </a:solidFill>
-                <a:latin typeface="Calibri"/>
-              </a:rPr>
-              <a:t>O INEP </a:t>
-            </a:r>
-            <a:r>
-              <a:rPr sz="1500" dirty="0" err="1">
-                <a:solidFill>
-                  <a:srgbClr val="444444"/>
-                </a:solidFill>
-                <a:latin typeface="Calibri"/>
-              </a:rPr>
-              <a:t>definiu</a:t>
-            </a:r>
-            <a:r>
-              <a:rPr sz="1500" dirty="0">
-                <a:solidFill>
-                  <a:srgbClr val="444444"/>
-                </a:solidFill>
-                <a:latin typeface="Calibri"/>
-              </a:rPr>
-              <a:t> 743 </a:t>
-            </a:r>
-            <a:r>
-              <a:rPr sz="1500" dirty="0" err="1">
-                <a:solidFill>
-                  <a:srgbClr val="444444"/>
-                </a:solidFill>
-                <a:latin typeface="Calibri"/>
-              </a:rPr>
-              <a:t>pontos</a:t>
-            </a:r>
-            <a:r>
-              <a:rPr sz="1500" dirty="0">
-                <a:solidFill>
-                  <a:srgbClr val="444444"/>
-                </a:solidFill>
-                <a:latin typeface="Calibri"/>
-              </a:rPr>
-              <a:t> </a:t>
-            </a:r>
-            <a:r>
-              <a:rPr sz="1500" dirty="0" err="1">
-                <a:solidFill>
-                  <a:srgbClr val="444444"/>
-                </a:solidFill>
-                <a:latin typeface="Calibri"/>
-              </a:rPr>
-              <a:t>na</a:t>
-            </a:r>
-            <a:r>
-              <a:rPr sz="1500" dirty="0">
-                <a:solidFill>
-                  <a:srgbClr val="444444"/>
-                </a:solidFill>
-                <a:latin typeface="Calibri"/>
-              </a:rPr>
-              <a:t> </a:t>
-            </a:r>
-            <a:r>
-              <a:rPr sz="1500" dirty="0" err="1">
-                <a:solidFill>
-                  <a:srgbClr val="444444"/>
-                </a:solidFill>
-                <a:latin typeface="Calibri"/>
-              </a:rPr>
-              <a:t>escala</a:t>
-            </a:r>
-            <a:r>
-              <a:rPr sz="1500" dirty="0">
-                <a:solidFill>
-                  <a:srgbClr val="444444"/>
-                </a:solidFill>
-                <a:latin typeface="Calibri"/>
-              </a:rPr>
-              <a:t> de </a:t>
-            </a:r>
-            <a:r>
-              <a:rPr sz="1500" dirty="0" err="1">
-                <a:solidFill>
-                  <a:srgbClr val="444444"/>
-                </a:solidFill>
-                <a:latin typeface="Calibri"/>
-              </a:rPr>
-              <a:t>proficiência</a:t>
-            </a:r>
-            <a:r>
-              <a:rPr sz="1500" dirty="0">
-                <a:solidFill>
-                  <a:srgbClr val="444444"/>
-                </a:solidFill>
-                <a:latin typeface="Calibri"/>
-              </a:rPr>
-              <a:t> do Saeb </a:t>
-            </a:r>
-            <a:r>
-              <a:rPr sz="1500" dirty="0" err="1">
-                <a:solidFill>
-                  <a:srgbClr val="444444"/>
-                </a:solidFill>
-                <a:latin typeface="Calibri"/>
-              </a:rPr>
-              <a:t>como</a:t>
-            </a:r>
-            <a:r>
-              <a:rPr sz="1500" dirty="0">
-                <a:solidFill>
-                  <a:srgbClr val="444444"/>
-                </a:solidFill>
-                <a:latin typeface="Calibri"/>
-              </a:rPr>
-              <a:t> o corte de </a:t>
-            </a:r>
-            <a:r>
-              <a:rPr sz="1500" dirty="0" err="1">
-                <a:solidFill>
-                  <a:srgbClr val="444444"/>
-                </a:solidFill>
-                <a:latin typeface="Calibri"/>
-              </a:rPr>
-              <a:t>alfabetização</a:t>
-            </a:r>
-            <a:r>
-              <a:rPr sz="1500" dirty="0">
-                <a:solidFill>
-                  <a:srgbClr val="444444"/>
-                </a:solidFill>
-                <a:latin typeface="Calibri"/>
-              </a:rPr>
-              <a:t>, </a:t>
-            </a:r>
-            <a:r>
-              <a:rPr sz="1500" dirty="0" err="1">
-                <a:solidFill>
-                  <a:srgbClr val="444444"/>
-                </a:solidFill>
-                <a:latin typeface="Calibri"/>
-              </a:rPr>
-              <a:t>criando</a:t>
-            </a:r>
-            <a:r>
-              <a:rPr sz="1500" dirty="0">
-                <a:solidFill>
-                  <a:srgbClr val="444444"/>
-                </a:solidFill>
-                <a:latin typeface="Calibri"/>
-              </a:rPr>
-              <a:t> o </a:t>
-            </a:r>
-            <a:r>
-              <a:rPr sz="1500" dirty="0" err="1">
-                <a:solidFill>
-                  <a:srgbClr val="444444"/>
-                </a:solidFill>
-                <a:latin typeface="Calibri"/>
-              </a:rPr>
-              <a:t>Indicador</a:t>
-            </a:r>
-            <a:r>
-              <a:rPr sz="1500" dirty="0">
-                <a:solidFill>
-                  <a:srgbClr val="444444"/>
-                </a:solidFill>
-                <a:latin typeface="Calibri"/>
-              </a:rPr>
-              <a:t> </a:t>
-            </a:r>
-            <a:r>
-              <a:rPr sz="1500" dirty="0" err="1">
-                <a:solidFill>
-                  <a:srgbClr val="444444"/>
-                </a:solidFill>
-                <a:latin typeface="Calibri"/>
-              </a:rPr>
-              <a:t>Criança</a:t>
-            </a:r>
-            <a:r>
-              <a:rPr sz="1500" dirty="0">
-                <a:solidFill>
-                  <a:srgbClr val="444444"/>
-                </a:solidFill>
-                <a:latin typeface="Calibri"/>
-              </a:rPr>
-              <a:t> </a:t>
-            </a:r>
-            <a:r>
-              <a:rPr sz="1500" dirty="0" err="1">
-                <a:solidFill>
-                  <a:srgbClr val="444444"/>
-                </a:solidFill>
-                <a:latin typeface="Calibri"/>
-              </a:rPr>
-              <a:t>Alfabetizada</a:t>
-            </a:r>
-            <a:r>
-              <a:rPr sz="1500" dirty="0">
-                <a:solidFill>
-                  <a:srgbClr val="444444"/>
-                </a:solidFill>
-                <a:latin typeface="Calibri"/>
-              </a:rPr>
-              <a:t>.</a:t>
-            </a:r>
+              <a:rPr lang="pt-BR" sz="1500" dirty="0">
+                <a:solidFill>
+                  <a:srgbClr val="444444"/>
+                </a:solidFill>
+                <a:latin typeface="Calibri"/>
+              </a:rPr>
+              <a:t>Em 2025, 66,0% das crianças avaliadas atingem esse patamar — a meta é 80,0% até 2030.</a:t>
+            </a:r>
+            <a:endParaRPr sz="1500" dirty="0">
+              <a:solidFill>
+                <a:srgbClr val="444444"/>
+              </a:solidFill>
+              <a:latin typeface="Calibri"/>
+            </a:endParaRPr>
           </a:p>
           <a:p>
             <a:pPr>
@@ -4249,13 +4071,22 @@
               <a:t>▶  </a:t>
             </a:r>
             <a:r>
+              <a:rPr sz="1500" dirty="0">
+                <a:solidFill>
+                  <a:srgbClr val="444444"/>
+                </a:solidFill>
+                <a:latin typeface="Calibri"/>
+              </a:rPr>
+              <a:t>O INEP </a:t>
+            </a:r>
+            <a:r>
               <a:rPr sz="1500" dirty="0" err="1">
                 <a:solidFill>
                   <a:srgbClr val="444444"/>
                 </a:solidFill>
                 <a:latin typeface="Calibri"/>
               </a:rPr>
-              <a:t>Hoje</a:t>
+              <a:t>definiu</a:t>
             </a:r>
             <a:r>
               <a:rPr sz="1500" dirty="0">
@@ -4264,7 +4095,7 @@
                 </a:solidFill>
                 <a:latin typeface="Calibri"/>
               </a:rPr>
-              <a:t> (2025), 66,0% das </a:t>
+              <a:t> 743 </a:t>
             </a:r>
             <a:r>
               <a:rPr sz="1500" dirty="0" err="1">
@@ -4273,7 +4104,7 @@
                 </a:solidFill>
                 <a:latin typeface="Calibri"/>
               </a:rPr>
-              <a:t>crianças</a:t>
+              <a:t>pontos</a:t>
             </a:r>
             <a:r>
               <a:rPr sz="1500" dirty="0">
@@ -4291,7 +4122,7 @@
                 </a:solidFill>
                 <a:latin typeface="Calibri"/>
               </a:rPr>
-              <a:t>avaliadas</a:t>
+              <a:t>na</a:t>
             </a:r>
             <a:r>
               <a:rPr sz="1500" dirty="0">
@@ -4309,7 +4140,7 @@
                 </a:solidFill>
                 <a:latin typeface="Calibri"/>
               </a:rPr>
-              <a:t>atingem</a:t>
+              <a:t>escala</a:t>
             </a:r>
             <a:r>
               <a:rPr sz="1500" dirty="0">
@@ -4318,7 +4149,7 @@
                 </a:solidFill>
                 <a:latin typeface="Calibri"/>
               </a:rPr>
-              <a:t> esse patamar — a meta é 80,0% </a:t>
+              <a:t> de </a:t>
             </a:r>
             <a:r>
               <a:rPr sz="1500" dirty="0" err="1">
@@ -4327,7 +4158,7 @@
                 </a:solidFill>
                 <a:latin typeface="Calibri"/>
               </a:rPr>
-              <a:t>até</a:t>
+              <a:t>proficiência</a:t>
             </a:r>
             <a:r>
               <a:rPr sz="1500" dirty="0">
@@ -4336,7 +4167,124 @@
                 </a:solidFill>
                 <a:latin typeface="Calibri"/>
               </a:rPr>
-              <a:t> 2030.</a:t>
+              <a:t> do Saeb </a:t>
+            </a:r>
+            <a:r>
+              <a:rPr lang="pt-BR" sz="1500" dirty="0">
+                <a:solidFill>
+                  <a:srgbClr val="444444"/>
+                </a:solidFill>
+                <a:latin typeface="Calibri"/>
+              </a:rPr>
+              <a:t>(Sistema de Avaliação da Educação Básica) </a:t>
+            </a:r>
+            <a:r>
+              <a:rPr sz="1500" dirty="0" err="1">
+                <a:solidFill>
+                  <a:srgbClr val="444444"/>
+                </a:solidFill>
+                <a:latin typeface="Calibri"/>
+              </a:rPr>
+              <a:t>como</a:t>
+            </a:r>
+            <a:r>
+              <a:rPr sz="1500" dirty="0">
+                <a:solidFill>
+                  <a:srgbClr val="444444"/>
+                </a:solidFill>
+                <a:latin typeface="Calibri"/>
+              </a:rPr>
+              <a:t> o corte de </a:t>
+            </a:r>
+            <a:r>
+              <a:rPr sz="1500" dirty="0" err="1">
+                <a:solidFill>
+                  <a:srgbClr val="444444"/>
+                </a:solidFill>
+                <a:latin typeface="Calibri"/>
+              </a:rPr>
+              <a:t>alfabetização</a:t>
+            </a:r>
+            <a:r>
+              <a:rPr sz="1500" dirty="0">
+                <a:solidFill>
+                  <a:srgbClr val="444444"/>
+                </a:solidFill>
+                <a:latin typeface="Calibri"/>
+              </a:rPr>
+              <a:t>, </a:t>
+            </a:r>
+            <a:r>
+              <a:rPr sz="1500" dirty="0" err="1">
+                <a:solidFill>
+                  <a:srgbClr val="444444"/>
+                </a:solidFill>
+                <a:latin typeface="Calibri"/>
+              </a:rPr>
+              <a:t>criando</a:t>
+            </a:r>
+            <a:r>
+              <a:rPr sz="1500" dirty="0">
+                <a:solidFill>
+                  <a:srgbClr val="444444"/>
+                </a:solidFill>
+                <a:latin typeface="Calibri"/>
+              </a:rPr>
+              <a:t> o </a:t>
+            </a:r>
+            <a:r>
+              <a:rPr sz="1500" dirty="0" err="1">
+                <a:solidFill>
+                  <a:srgbClr val="444444"/>
+                </a:solidFill>
+                <a:latin typeface="Calibri"/>
+              </a:rPr>
+              <a:t>Indicador</a:t>
+            </a:r>
+            <a:r>
+              <a:rPr sz="1500" dirty="0">
+                <a:solidFill>
+                  <a:srgbClr val="444444"/>
+                </a:solidFill>
+                <a:latin typeface="Calibri"/>
+              </a:rPr>
+              <a:t> </a:t>
+            </a:r>
+            <a:r>
+              <a:rPr sz="1500" dirty="0" err="1">
+                <a:solidFill>
+                  <a:srgbClr val="444444"/>
+                </a:solidFill>
+                <a:latin typeface="Calibri"/>
+              </a:rPr>
+              <a:t>Criança</a:t>
+            </a:r>
+            <a:r>
+              <a:rPr sz="1500" dirty="0">
+                <a:solidFill>
+                  <a:srgbClr val="444444"/>
+                </a:solidFill>
+                <a:latin typeface="Calibri"/>
+              </a:rPr>
+              <a:t> </a:t>
+            </a:r>
+            <a:r>
+              <a:rPr sz="1500" dirty="0" err="1">
+                <a:solidFill>
+                  <a:srgbClr val="444444"/>
+                </a:solidFill>
+                <a:latin typeface="Calibri"/>
+              </a:rPr>
+              <a:t>Alfabetizada</a:t>
+            </a:r>
+            <a:r>
+              <a:rPr sz="1500" dirty="0">
+                <a:solidFill>
+                  <a:srgbClr val="444444"/>
+                </a:solidFill>
+                <a:latin typeface="Calibri"/>
+              </a:rPr>
+              <a:t>.</a:t>
             </a:r>
           </a:p>
           <a:p>
@@ -4346,7 +4294,7 @@
               </a:spcAft>
             </a:pPr>
             <a:r>
-              <a:rPr sz="1500" b="1" dirty="0">
+              <a:rPr lang="pt-BR" sz="1500" b="1" dirty="0">
                 <a:solidFill>
                   <a:srgbClr val="2E86C1"/>
                 </a:solidFill>
@@ -4361,205 +4309,7 @@
                 </a:solidFill>
                 <a:latin typeface="Calibri"/>
               </a:rPr>
-              <a:t>Dados não integrados e sem acompanhamento de</a:t>
-            </a:r>
-            <a:r>
-              <a:rPr sz="1500" dirty="0">
-                <a:solidFill>
-                  <a:srgbClr val="444444"/>
-                </a:solidFill>
-                <a:latin typeface="Calibri"/>
-              </a:rPr>
-              <a:t> </a:t>
-            </a:r>
-            <a:r>
-              <a:rPr sz="1500" dirty="0" err="1">
-                <a:solidFill>
-                  <a:srgbClr val="444444"/>
-                </a:solidFill>
-                <a:latin typeface="Calibri"/>
-              </a:rPr>
-              <a:t>resultado</a:t>
-            </a:r>
-            <a:r>
-              <a:rPr lang="pt-BR" sz="1500" dirty="0">
-                <a:solidFill>
-                  <a:srgbClr val="444444"/>
-                </a:solidFill>
-                <a:latin typeface="Calibri"/>
-              </a:rPr>
-              <a:t>s</a:t>
-            </a:r>
-            <a:r>
-              <a:rPr sz="1500" dirty="0">
-                <a:solidFill>
-                  <a:srgbClr val="444444"/>
-                </a:solidFill>
-                <a:latin typeface="Calibri"/>
-              </a:rPr>
-              <a:t>, </a:t>
-            </a:r>
-            <a:r>
-              <a:rPr sz="1500" dirty="0" err="1">
-                <a:solidFill>
-                  <a:srgbClr val="444444"/>
-                </a:solidFill>
-                <a:latin typeface="Calibri"/>
-              </a:rPr>
-              <a:t>metas</a:t>
-            </a:r>
-            <a:r>
-              <a:rPr sz="1500" dirty="0">
-                <a:solidFill>
-                  <a:srgbClr val="444444"/>
-                </a:solidFill>
-                <a:latin typeface="Calibri"/>
-              </a:rPr>
-              <a:t>, </a:t>
-            </a:r>
-            <a:r>
-              <a:rPr sz="1500" dirty="0" err="1">
-                <a:solidFill>
-                  <a:srgbClr val="444444"/>
-                </a:solidFill>
-                <a:latin typeface="Calibri"/>
-              </a:rPr>
-              <a:t>território</a:t>
-            </a:r>
-            <a:r>
-              <a:rPr sz="1500" dirty="0">
-                <a:solidFill>
-                  <a:srgbClr val="444444"/>
-                </a:solidFill>
-                <a:latin typeface="Calibri"/>
-              </a:rPr>
-              <a:t> e </a:t>
-            </a:r>
-            <a:r>
-              <a:rPr sz="1500" dirty="0" err="1">
-                <a:solidFill>
-                  <a:srgbClr val="444444"/>
-                </a:solidFill>
-                <a:latin typeface="Calibri"/>
-              </a:rPr>
-              <a:t>contexto</a:t>
-            </a:r>
-            <a:r>
-              <a:rPr sz="1500" dirty="0">
-                <a:solidFill>
-                  <a:srgbClr val="444444"/>
-                </a:solidFill>
-                <a:latin typeface="Calibri"/>
-              </a:rPr>
-              <a:t> </a:t>
-            </a:r>
-            <a:r>
-              <a:rPr sz="1500" dirty="0" err="1">
-                <a:solidFill>
-                  <a:srgbClr val="444444"/>
-                </a:solidFill>
-                <a:latin typeface="Calibri"/>
-              </a:rPr>
-              <a:t>socioeconômico</a:t>
-            </a:r>
-            <a:r>
-              <a:rPr sz="1500" dirty="0">
-                <a:solidFill>
-                  <a:srgbClr val="444444"/>
-                </a:solidFill>
-                <a:latin typeface="Calibri"/>
-              </a:rPr>
-              <a:t>, </a:t>
-            </a:r>
-            <a:r>
-              <a:rPr sz="1500" dirty="0" err="1">
-                <a:solidFill>
-                  <a:srgbClr val="444444"/>
-                </a:solidFill>
-                <a:latin typeface="Calibri"/>
-              </a:rPr>
-              <a:t>gestores</a:t>
-            </a:r>
-            <a:r>
-              <a:rPr sz="1500" dirty="0">
-                <a:solidFill>
-                  <a:srgbClr val="444444"/>
-                </a:solidFill>
-                <a:latin typeface="Calibri"/>
-              </a:rPr>
-              <a:t> não </a:t>
-            </a:r>
-            <a:r>
-              <a:rPr sz="1500" dirty="0" err="1">
-                <a:solidFill>
-                  <a:srgbClr val="444444"/>
-                </a:solidFill>
-                <a:latin typeface="Calibri"/>
-              </a:rPr>
-              <a:t>enxergam</a:t>
-            </a:r>
-            <a:r>
-              <a:rPr sz="1500" dirty="0">
-                <a:solidFill>
-                  <a:srgbClr val="444444"/>
-                </a:solidFill>
-                <a:latin typeface="Calibri"/>
-              </a:rPr>
-              <a:t> </a:t>
-            </a:r>
-            <a:r>
-              <a:rPr sz="1500" dirty="0" err="1">
-                <a:solidFill>
-                  <a:srgbClr val="444444"/>
-                </a:solidFill>
-                <a:latin typeface="Calibri"/>
-              </a:rPr>
-              <a:t>onde</a:t>
-            </a:r>
-            <a:r>
-              <a:rPr sz="1500" dirty="0">
-                <a:solidFill>
-                  <a:srgbClr val="444444"/>
-                </a:solidFill>
-                <a:latin typeface="Calibri"/>
-              </a:rPr>
-              <a:t> </a:t>
-            </a:r>
-            <a:r>
-              <a:rPr sz="1500" dirty="0" err="1">
-                <a:solidFill>
-                  <a:srgbClr val="444444"/>
-                </a:solidFill>
-                <a:latin typeface="Calibri"/>
-              </a:rPr>
-              <a:t>agir</a:t>
-            </a:r>
-            <a:r>
-              <a:rPr sz="1500" dirty="0">
-                <a:solidFill>
-                  <a:srgbClr val="444444"/>
-                </a:solidFill>
-                <a:latin typeface="Calibri"/>
-              </a:rPr>
-              <a:t> </a:t>
-            </a:r>
-            <a:r>
-              <a:rPr sz="1500" dirty="0" err="1">
-                <a:solidFill>
-                  <a:srgbClr val="444444"/>
-                </a:solidFill>
-                <a:latin typeface="Calibri"/>
-              </a:rPr>
-              <a:t>primeiro</a:t>
-            </a:r>
-            <a:r>
-              <a:rPr sz="1500" dirty="0">
-                <a:solidFill>
-                  <a:srgbClr val="444444"/>
-                </a:solidFill>
-                <a:latin typeface="Calibri"/>
-              </a:rPr>
-              <a:t>.</a:t>
+              <a:t>Dados não integrados e sem acompanhamento de resultados, metas, território e contexto socioeconômico, gestores não enxergam onde agir primeiro.</a:t>
             </a:r>
           </a:p>
         </p:txBody>
@@ -4608,7 +4358,7 @@
         <p:spPr>
           <a:xfrm>
             <a:off x="365760" y="4892040"/>
-            <a:ext cx="11430000" cy="1234440"/>
+            <a:ext cx="9439143" cy="1234440"/>
           </a:xfrm>
           <a:prstGeom prst="roundRect">
             <a:avLst>
@@ -4656,8 +4406,8 @@
         </p:nvSpPr>
         <p:spPr>
           <a:xfrm>
-            <a:off x="640080" y="5074920"/>
-            <a:ext cx="10881360" cy="914400"/>
+            <a:off x="640080" y="5224343"/>
+            <a:ext cx="9098280" cy="615553"/>
           </a:xfrm>
           <a:prstGeom prst="rect">
             <a:avLst/>
@@ -4672,13 +4422,319 @@
           <a:p>
             <a:pPr algn="l"/>
             <a:r>
-              <a:rPr sz="1700" b="0" i="1">
+              <a:rPr sz="1700" b="0" i="1" dirty="0">
                 <a:solidFill>
                   <a:srgbClr val="1A253A"/>
                 </a:solidFill>
                 <a:latin typeface="Calibri"/>
               </a:rPr>
-              <a:t>“Como transformar dados dispersos do INEP em uma base confiável, atualizada e pronta para decisão — mostrando quem está evoluindo, quem está estagnado, e por quê?”</a:t>
+              <a:t>“Como </a:t>
+            </a:r>
+            <a:r>
+              <a:rPr sz="1700" b="0" i="1" dirty="0" err="1">
+                <a:solidFill>
+                  <a:srgbClr val="1A253A"/>
+                </a:solidFill>
+                <a:latin typeface="Calibri"/>
+              </a:rPr>
+              <a:t>transformar</a:t>
+            </a:r>
+            <a:r>
+              <a:rPr sz="1700" b="0" i="1" dirty="0">
+                <a:solidFill>
+                  <a:srgbClr val="1A253A"/>
+                </a:solidFill>
+                <a:latin typeface="Calibri"/>
+              </a:rPr>
+              <a:t> dados </a:t>
+            </a:r>
+            <a:r>
+              <a:rPr sz="1700" b="0" i="1" dirty="0" err="1">
+                <a:solidFill>
+                  <a:srgbClr val="1A253A"/>
+                </a:solidFill>
+                <a:latin typeface="Calibri"/>
+              </a:rPr>
+              <a:t>dispersos</a:t>
+            </a:r>
+            <a:r>
+              <a:rPr sz="1700" b="0" i="1" dirty="0">
+                <a:solidFill>
+                  <a:srgbClr val="1A253A"/>
+                </a:solidFill>
+                <a:latin typeface="Calibri"/>
+              </a:rPr>
+              <a:t> do INEP </a:t>
+            </a:r>
+            <a:r>
+              <a:rPr sz="1700" b="0" i="1" dirty="0" err="1">
+                <a:solidFill>
+                  <a:srgbClr val="1A253A"/>
+                </a:solidFill>
+                <a:latin typeface="Calibri"/>
+              </a:rPr>
+              <a:t>em</a:t>
+            </a:r>
+            <a:r>
+              <a:rPr sz="1700" b="0" i="1" dirty="0">
+                <a:solidFill>
+                  <a:srgbClr val="1A253A"/>
+                </a:solidFill>
+                <a:latin typeface="Calibri"/>
+              </a:rPr>
+              <a:t> </a:t>
+            </a:r>
+            <a:r>
+              <a:rPr sz="1700" b="0" i="1" dirty="0" err="1">
+                <a:solidFill>
+                  <a:srgbClr val="1A253A"/>
+                </a:solidFill>
+                <a:latin typeface="Calibri"/>
+              </a:rPr>
+              <a:t>uma</a:t>
+            </a:r>
+            <a:r>
+              <a:rPr sz="1700" b="0" i="1" dirty="0">
+                <a:solidFill>
+                  <a:srgbClr val="1A253A"/>
+                </a:solidFill>
+                <a:latin typeface="Calibri"/>
+              </a:rPr>
+              <a:t> base </a:t>
+            </a:r>
+            <a:r>
+              <a:rPr sz="1700" b="0" i="1" dirty="0" err="1">
+                <a:solidFill>
+                  <a:srgbClr val="1A253A"/>
+                </a:solidFill>
+                <a:latin typeface="Calibri"/>
+              </a:rPr>
+              <a:t>confiável</a:t>
+            </a:r>
+            <a:r>
+              <a:rPr sz="1700" b="0" i="1" dirty="0">
+                <a:solidFill>
+                  <a:srgbClr val="1A253A"/>
+                </a:solidFill>
+                <a:latin typeface="Calibri"/>
+              </a:rPr>
+              <a:t>, </a:t>
+            </a:r>
+            <a:r>
+              <a:rPr sz="1700" b="0" i="1" dirty="0" err="1">
+                <a:solidFill>
+                  <a:srgbClr val="1A253A"/>
+                </a:solidFill>
+                <a:latin typeface="Calibri"/>
+              </a:rPr>
+              <a:t>atualizada</a:t>
+            </a:r>
+            <a:r>
+              <a:rPr sz="1700" b="0" i="1" dirty="0">
+                <a:solidFill>
+                  <a:srgbClr val="1A253A"/>
+                </a:solidFill>
+                <a:latin typeface="Calibri"/>
+              </a:rPr>
+              <a:t> e </a:t>
+            </a:r>
+            <a:r>
+              <a:rPr sz="1700" b="0" i="1" dirty="0" err="1">
+                <a:solidFill>
+                  <a:srgbClr val="1A253A"/>
+                </a:solidFill>
+                <a:latin typeface="Calibri"/>
+              </a:rPr>
+              <a:t>pronta</a:t>
+            </a:r>
+            <a:r>
+              <a:rPr sz="1700" b="0" i="1" dirty="0">
+                <a:solidFill>
+                  <a:srgbClr val="1A253A"/>
+                </a:solidFill>
+                <a:latin typeface="Calibri"/>
+              </a:rPr>
+              <a:t> para </a:t>
+            </a:r>
+            <a:r>
+              <a:rPr sz="1700" b="0" i="1" dirty="0" err="1">
+                <a:solidFill>
+                  <a:srgbClr val="1A253A"/>
+                </a:solidFill>
+                <a:latin typeface="Calibri"/>
+              </a:rPr>
+              <a:t>decisão</a:t>
+            </a:r>
+            <a:r>
+              <a:rPr sz="1700" b="0" i="1" dirty="0">
+                <a:solidFill>
+                  <a:srgbClr val="1A253A"/>
+                </a:solidFill>
+                <a:latin typeface="Calibri"/>
+              </a:rPr>
+              <a:t> — </a:t>
+            </a:r>
+            <a:r>
+              <a:rPr sz="1700" b="0" i="1" dirty="0" err="1">
+                <a:solidFill>
+                  <a:srgbClr val="1A253A"/>
+                </a:solidFill>
+                <a:latin typeface="Calibri"/>
+              </a:rPr>
+              <a:t>mostrando</a:t>
+            </a:r>
+            <a:r>
+              <a:rPr sz="1700" b="0" i="1" dirty="0">
+                <a:solidFill>
+                  <a:srgbClr val="1A253A"/>
+                </a:solidFill>
+                <a:latin typeface="Calibri"/>
+              </a:rPr>
+              <a:t> </a:t>
+            </a:r>
+            <a:r>
+              <a:rPr sz="1700" b="0" i="1" dirty="0" err="1">
+                <a:solidFill>
+                  <a:srgbClr val="1A253A"/>
+                </a:solidFill>
+                <a:latin typeface="Calibri"/>
+              </a:rPr>
+              <a:t>quem</a:t>
+            </a:r>
+            <a:r>
+              <a:rPr sz="1700" b="0" i="1" dirty="0">
+                <a:solidFill>
+                  <a:srgbClr val="1A253A"/>
+                </a:solidFill>
+                <a:latin typeface="Calibri"/>
+              </a:rPr>
+              <a:t> </a:t>
+            </a:r>
+            <a:r>
+              <a:rPr sz="1700" b="0" i="1" dirty="0" err="1">
+                <a:solidFill>
+                  <a:srgbClr val="1A253A"/>
+                </a:solidFill>
+                <a:latin typeface="Calibri"/>
+              </a:rPr>
+              <a:t>está</a:t>
+            </a:r>
+            <a:r>
+              <a:rPr sz="1700" b="0" i="1" dirty="0">
+                <a:solidFill>
+                  <a:srgbClr val="1A253A"/>
+                </a:solidFill>
+                <a:latin typeface="Calibri"/>
+              </a:rPr>
+              <a:t> </a:t>
+            </a:r>
+            <a:r>
+              <a:rPr sz="1700" b="0" i="1" dirty="0" err="1">
+                <a:solidFill>
+                  <a:srgbClr val="1A253A"/>
+                </a:solidFill>
+                <a:latin typeface="Calibri"/>
+              </a:rPr>
+              <a:t>evoluindo</a:t>
+            </a:r>
+            <a:r>
+              <a:rPr sz="1700" b="0" i="1" dirty="0">
+                <a:solidFill>
+                  <a:srgbClr val="1A253A"/>
+                </a:solidFill>
+                <a:latin typeface="Calibri"/>
+              </a:rPr>
+              <a:t>, </a:t>
+            </a:r>
+            <a:r>
+              <a:rPr sz="1700" b="0" i="1" dirty="0" err="1">
+                <a:solidFill>
+                  <a:srgbClr val="1A253A"/>
+                </a:solidFill>
+                <a:latin typeface="Calibri"/>
+              </a:rPr>
+              <a:t>quem</a:t>
+            </a:r>
+            <a:r>
+              <a:rPr sz="1700" b="0" i="1" dirty="0">
+                <a:solidFill>
+                  <a:srgbClr val="1A253A"/>
+                </a:solidFill>
+                <a:latin typeface="Calibri"/>
+              </a:rPr>
+              <a:t> </a:t>
+            </a:r>
+            <a:r>
+              <a:rPr sz="1700" b="0" i="1" dirty="0" err="1">
+                <a:solidFill>
+                  <a:srgbClr val="1A253A"/>
+                </a:solidFill>
+                <a:latin typeface="Calibri"/>
+              </a:rPr>
+              <a:t>está</a:t>
+            </a:r>
+            <a:r>
+              <a:rPr sz="1700" b="0" i="1" dirty="0">
+                <a:solidFill>
+                  <a:srgbClr val="1A253A"/>
+                </a:solidFill>
+                <a:latin typeface="Calibri"/>
+              </a:rPr>
+              <a:t> </a:t>
+            </a:r>
+            <a:r>
+              <a:rPr sz="1700" b="0" i="1" dirty="0" err="1">
+                <a:solidFill>
+                  <a:srgbClr val="1A253A"/>
+                </a:solidFill>
+                <a:latin typeface="Calibri"/>
+              </a:rPr>
+              <a:t>estagnado</a:t>
+            </a:r>
+            <a:r>
+              <a:rPr sz="1700" b="0" i="1" dirty="0">
+                <a:solidFill>
+                  <a:srgbClr val="1A253A"/>
+                </a:solidFill>
+                <a:latin typeface="Calibri"/>
+              </a:rPr>
+              <a:t>, e </a:t>
+            </a:r>
+            <a:r>
+              <a:rPr sz="1700" b="0" i="1" dirty="0" err="1">
+                <a:solidFill>
+                  <a:srgbClr val="1A253A"/>
+                </a:solidFill>
+                <a:latin typeface="Calibri"/>
+              </a:rPr>
+              <a:t>por</a:t>
+            </a:r>
+            <a:r>
+              <a:rPr sz="1700" b="0" i="1" dirty="0">
+                <a:solidFill>
+                  <a:srgbClr val="1A253A"/>
+                </a:solidFill>
+                <a:latin typeface="Calibri"/>
+              </a:rPr>
+              <a:t> </a:t>
+            </a:r>
+            <a:r>
+              <a:rPr sz="1700" b="0" i="1" dirty="0" err="1">
+                <a:solidFill>
+                  <a:srgbClr val="1A253A"/>
+                </a:solidFill>
+                <a:latin typeface="Calibri"/>
+              </a:rPr>
+              <a:t>quê</a:t>
+            </a:r>
+            <a:r>
+              <a:rPr sz="1700" b="0" i="1" dirty="0">
+                <a:solidFill>
+                  <a:srgbClr val="1A253A"/>
+                </a:solidFill>
+                <a:latin typeface="Calibri"/>
+              </a:rPr>
+              <a:t>?”</a:t>
             </a:r>
           </a:p>
         </p:txBody>
@@ -4688,6 +4744,14 @@
   <p:clrMapOvr>
     <a:masterClrMapping/>
   </p:clrMapOvr>
+  <mc:AlternateContent xmlns:mc="http://schemas.openxmlformats.org/markup-compatibility/2006" xmlns:p14="http://schemas.microsoft.com/office/powerpoint/2010/main">
+    <mc:Choice Requires="p14">
+      <p:transition spd="slow" p14:dur="2000" advTm="83989"/>
+    </mc:Choice>
+    <mc:Fallback xmlns="">
+      <p:transition spd="slow" advTm="83989"/>
+    </mc:Fallback>
+  </mc:AlternateContent>
 </p:sld>
 </file>
 
@@ -5920,6 +5984,14 @@
   <p:clrMapOvr>
     <a:masterClrMapping/>
   </p:clrMapOvr>
+  <mc:AlternateContent xmlns:mc="http://schemas.openxmlformats.org/markup-compatibility/2006" xmlns:p14="http://schemas.microsoft.com/office/powerpoint/2010/main">
+    <mc:Choice Requires="p14">
+      <p:transition spd="slow" p14:dur="2000" advTm="14006"/>
+    </mc:Choice>
+    <mc:Fallback xmlns="">
+      <p:transition spd="slow" advTm="14006"/>
+    </mc:Fallback>
+  </mc:AlternateContent>
 </p:sld>
 </file>
 
@@ -6981,7 +7053,7 @@
         <p:spPr>
           <a:xfrm>
             <a:off x="457200" y="3520440"/>
-            <a:ext cx="11247120" cy="2743200"/>
+            <a:ext cx="11247120" cy="1069524"/>
           </a:xfrm>
           <a:prstGeom prst="rect">
             <a:avLst/>
@@ -7168,133 +7240,7 @@
                 </a:solidFill>
                 <a:latin typeface="Calibri"/>
               </a:rPr>
-              <a:t> (streaming) — o </a:t>
-            </a:r>
-            <a:r>
-              <a:rPr sz="1450" dirty="0" err="1">
-                <a:solidFill>
-                  <a:srgbClr val="444444"/>
-                </a:solidFill>
-                <a:latin typeface="Calibri"/>
-              </a:rPr>
-              <a:t>mesmo</a:t>
-            </a:r>
-            <a:r>
-              <a:rPr sz="1450" dirty="0">
-                <a:solidFill>
-                  <a:srgbClr val="444444"/>
-                </a:solidFill>
-                <a:latin typeface="Calibri"/>
-              </a:rPr>
-              <a:t> </a:t>
-            </a:r>
-            <a:r>
-              <a:rPr sz="1450" dirty="0" err="1">
-                <a:solidFill>
-                  <a:srgbClr val="444444"/>
-                </a:solidFill>
-                <a:latin typeface="Calibri"/>
-              </a:rPr>
-              <a:t>padrão</a:t>
-            </a:r>
-            <a:r>
-              <a:rPr sz="1450" dirty="0">
-                <a:solidFill>
-                  <a:srgbClr val="444444"/>
-                </a:solidFill>
-                <a:latin typeface="Calibri"/>
-              </a:rPr>
-              <a:t> </a:t>
-            </a:r>
-            <a:r>
-              <a:rPr sz="1450" dirty="0" err="1">
-                <a:solidFill>
-                  <a:srgbClr val="444444"/>
-                </a:solidFill>
-                <a:latin typeface="Calibri"/>
-              </a:rPr>
-              <a:t>usado</a:t>
-            </a:r>
-            <a:r>
-              <a:rPr sz="1450" dirty="0">
-                <a:solidFill>
-                  <a:srgbClr val="444444"/>
-                </a:solidFill>
-                <a:latin typeface="Calibri"/>
-              </a:rPr>
-              <a:t> </a:t>
-            </a:r>
-            <a:r>
-              <a:rPr sz="1450" dirty="0" err="1">
-                <a:solidFill>
-                  <a:srgbClr val="444444"/>
-                </a:solidFill>
-                <a:latin typeface="Calibri"/>
-              </a:rPr>
-              <a:t>por</a:t>
-            </a:r>
-            <a:r>
-              <a:rPr sz="1450" dirty="0">
-                <a:solidFill>
-                  <a:srgbClr val="444444"/>
-                </a:solidFill>
-                <a:latin typeface="Calibri"/>
-              </a:rPr>
-              <a:t> </a:t>
-            </a:r>
-            <a:r>
-              <a:rPr sz="1450" dirty="0" err="1">
-                <a:solidFill>
-                  <a:srgbClr val="444444"/>
-                </a:solidFill>
-                <a:latin typeface="Calibri"/>
-              </a:rPr>
-              <a:t>bancos</a:t>
-            </a:r>
-            <a:r>
-              <a:rPr sz="1450" dirty="0">
-                <a:solidFill>
-                  <a:srgbClr val="444444"/>
-                </a:solidFill>
-                <a:latin typeface="Calibri"/>
-              </a:rPr>
-              <a:t> e fintechs para </a:t>
-            </a:r>
-            <a:r>
-              <a:rPr sz="1450" dirty="0" err="1">
-                <a:solidFill>
-                  <a:srgbClr val="444444"/>
-                </a:solidFill>
-                <a:latin typeface="Calibri"/>
-              </a:rPr>
-              <a:t>ingestão</a:t>
-            </a:r>
-            <a:r>
-              <a:rPr sz="1450" dirty="0">
-                <a:solidFill>
-                  <a:srgbClr val="444444"/>
-                </a:solidFill>
-                <a:latin typeface="Calibri"/>
-              </a:rPr>
-              <a:t> </a:t>
-            </a:r>
-            <a:r>
-              <a:rPr sz="1450" dirty="0" err="1">
-                <a:solidFill>
-                  <a:srgbClr val="444444"/>
-                </a:solidFill>
-                <a:latin typeface="Calibri"/>
-              </a:rPr>
-              <a:t>contínua</a:t>
-            </a:r>
-            <a:r>
-              <a:rPr sz="1450" dirty="0">
-                <a:solidFill>
-                  <a:srgbClr val="444444"/>
-                </a:solidFill>
-                <a:latin typeface="Calibri"/>
-              </a:rPr>
-              <a:t>.</a:t>
+              <a:t> (streaming).</a:t>
             </a:r>
           </a:p>
           <a:p>
@@ -7768,6 +7714,14 @@
   <p:clrMapOvr>
     <a:masterClrMapping/>
   </p:clrMapOvr>
+  <mc:AlternateContent xmlns:mc="http://schemas.openxmlformats.org/markup-compatibility/2006" xmlns:p14="http://schemas.microsoft.com/office/powerpoint/2010/main">
+    <mc:Choice Requires="p14">
+      <p:transition spd="slow" p14:dur="2000" advTm="33735"/>
+    </mc:Choice>
+    <mc:Fallback xmlns="">
+      <p:transition spd="slow" advTm="33735"/>
+    </mc:Fallback>
+  </mc:AlternateContent>
 </p:sld>
 </file>
 
@@ -9275,6 +9229,14 @@
   <p:clrMapOvr>
     <a:masterClrMapping/>
   </p:clrMapOvr>
+  <mc:AlternateContent xmlns:mc="http://schemas.openxmlformats.org/markup-compatibility/2006" xmlns:p14="http://schemas.microsoft.com/office/powerpoint/2010/main">
+    <mc:Choice Requires="p14">
+      <p:transition spd="slow" p14:dur="2000" advTm="48425"/>
+    </mc:Choice>
+    <mc:Fallback xmlns="">
+      <p:transition spd="slow" advTm="48425"/>
+    </mc:Fallback>
+  </mc:AlternateContent>
 </p:sld>
 </file>
 
@@ -10469,6 +10431,14 @@
   <p:clrMapOvr>
     <a:masterClrMapping/>
   </p:clrMapOvr>
+  <mc:AlternateContent xmlns:mc="http://schemas.openxmlformats.org/markup-compatibility/2006" xmlns:p14="http://schemas.microsoft.com/office/powerpoint/2010/main">
+    <mc:Choice Requires="p14">
+      <p:transition spd="slow" p14:dur="2000" advTm="13983"/>
+    </mc:Choice>
+    <mc:Fallback xmlns="">
+      <p:transition spd="slow" advTm="13983"/>
+    </mc:Fallback>
+  </mc:AlternateContent>
 </p:sld>
 </file>
 
@@ -11355,6 +11325,14 @@
   <p:clrMapOvr>
     <a:masterClrMapping/>
   </p:clrMapOvr>
+  <mc:AlternateContent xmlns:mc="http://schemas.openxmlformats.org/markup-compatibility/2006" xmlns:p14="http://schemas.microsoft.com/office/powerpoint/2010/main">
+    <mc:Choice Requires="p14">
+      <p:transition spd="slow" p14:dur="2000" advTm="29023"/>
+    </mc:Choice>
+    <mc:Fallback xmlns="">
+      <p:transition spd="slow" advTm="29023"/>
+    </mc:Fallback>
+  </mc:AlternateContent>
 </p:sld>
 </file>
 
@@ -11658,7 +11636,7 @@
         </p:nvSpPr>
         <p:spPr>
           <a:xfrm>
-            <a:off x="457200" y="2148840"/>
+            <a:off x="457200" y="1868635"/>
             <a:ext cx="9326880" cy="502920"/>
           </a:xfrm>
           <a:prstGeom prst="rect">
@@ -11703,7 +11681,7 @@
         </p:nvSpPr>
         <p:spPr>
           <a:xfrm>
-            <a:off x="594360" y="2240280"/>
+            <a:off x="594360" y="1960075"/>
             <a:ext cx="3657600" cy="365760"/>
           </a:xfrm>
           <a:prstGeom prst="rect">
@@ -11738,7 +11716,7 @@
         </p:nvSpPr>
         <p:spPr>
           <a:xfrm>
-            <a:off x="4434840" y="2240280"/>
+            <a:off x="4434840" y="1960075"/>
             <a:ext cx="2560320" cy="365760"/>
           </a:xfrm>
           <a:prstGeom prst="rect">
@@ -11773,7 +11751,7 @@
         </p:nvSpPr>
         <p:spPr>
           <a:xfrm>
-            <a:off x="7178040" y="2240280"/>
+            <a:off x="7178040" y="1960075"/>
             <a:ext cx="2560320" cy="365760"/>
           </a:xfrm>
           <a:prstGeom prst="rect">
@@ -11808,7 +11786,7 @@
         </p:nvSpPr>
         <p:spPr>
           <a:xfrm>
-            <a:off x="457200" y="2651760"/>
+            <a:off x="457200" y="2371555"/>
             <a:ext cx="9326880" cy="777240"/>
           </a:xfrm>
           <a:prstGeom prst="rect">
@@ -11855,7 +11833,7 @@
         </p:nvSpPr>
         <p:spPr>
           <a:xfrm>
-            <a:off x="457200" y="2651760"/>
+            <a:off x="457200" y="2371555"/>
             <a:ext cx="73152" cy="777240"/>
           </a:xfrm>
           <a:prstGeom prst="rect">
@@ -11900,7 +11878,7 @@
         </p:nvSpPr>
         <p:spPr>
           <a:xfrm>
-            <a:off x="640080" y="2834640"/>
+            <a:off x="640080" y="2554435"/>
             <a:ext cx="3566160" cy="457200"/>
           </a:xfrm>
           <a:prstGeom prst="rect">
@@ -11935,7 +11913,7 @@
         </p:nvSpPr>
         <p:spPr>
           <a:xfrm>
-            <a:off x="4480560" y="2834640"/>
+            <a:off x="4480560" y="2554435"/>
             <a:ext cx="2468880" cy="457200"/>
           </a:xfrm>
           <a:prstGeom prst="rect">
@@ -11970,7 +11948,7 @@
         </p:nvSpPr>
         <p:spPr>
           <a:xfrm>
-            <a:off x="7223760" y="2834640"/>
+            <a:off x="7223760" y="2554435"/>
             <a:ext cx="2468880" cy="457200"/>
           </a:xfrm>
           <a:prstGeom prst="rect">
@@ -12005,7 +11983,7 @@
         </p:nvSpPr>
         <p:spPr>
           <a:xfrm>
-            <a:off x="457200" y="3429000"/>
+            <a:off x="457200" y="3148795"/>
             <a:ext cx="9326880" cy="777240"/>
           </a:xfrm>
           <a:prstGeom prst="rect">
@@ -12052,7 +12030,7 @@
         </p:nvSpPr>
         <p:spPr>
           <a:xfrm>
-            <a:off x="457200" y="3429000"/>
+            <a:off x="457200" y="3148795"/>
             <a:ext cx="73152" cy="777240"/>
           </a:xfrm>
           <a:prstGeom prst="rect">
@@ -12097,7 +12075,7 @@
         </p:nvSpPr>
         <p:spPr>
           <a:xfrm>
-            <a:off x="640080" y="3611880"/>
+            <a:off x="640080" y="3331675"/>
             <a:ext cx="3566160" cy="457200"/>
           </a:xfrm>
           <a:prstGeom prst="rect">
@@ -12132,7 +12110,7 @@
         </p:nvSpPr>
         <p:spPr>
           <a:xfrm>
-            <a:off x="4480560" y="3611880"/>
+            <a:off x="4480560" y="3331675"/>
             <a:ext cx="2468880" cy="457200"/>
           </a:xfrm>
           <a:prstGeom prst="rect">
@@ -12167,7 +12145,7 @@
         </p:nvSpPr>
         <p:spPr>
           <a:xfrm>
-            <a:off x="7223760" y="3611880"/>
+            <a:off x="7223760" y="3331675"/>
             <a:ext cx="2468880" cy="457200"/>
           </a:xfrm>
           <a:prstGeom prst="rect">
@@ -12202,7 +12180,7 @@
         </p:nvSpPr>
         <p:spPr>
           <a:xfrm>
-            <a:off x="457200" y="4206240"/>
+            <a:off x="457200" y="3926035"/>
             <a:ext cx="9326880" cy="777240"/>
           </a:xfrm>
           <a:prstGeom prst="rect">
@@ -12249,7 +12227,7 @@
         </p:nvSpPr>
         <p:spPr>
           <a:xfrm>
-            <a:off x="457200" y="4206240"/>
+            <a:off x="457200" y="3926035"/>
             <a:ext cx="73152" cy="777240"/>
           </a:xfrm>
           <a:prstGeom prst="rect">
@@ -12294,7 +12272,7 @@
         </p:nvSpPr>
         <p:spPr>
           <a:xfrm>
-            <a:off x="640080" y="4389120"/>
+            <a:off x="640080" y="4108915"/>
             <a:ext cx="3566160" cy="457200"/>
           </a:xfrm>
           <a:prstGeom prst="rect">
@@ -12329,7 +12307,7 @@
         </p:nvSpPr>
         <p:spPr>
           <a:xfrm>
-            <a:off x="4480560" y="4389120"/>
+            <a:off x="4480560" y="4108915"/>
             <a:ext cx="2468880" cy="457200"/>
           </a:xfrm>
           <a:prstGeom prst="rect">
@@ -12364,7 +12342,7 @@
         </p:nvSpPr>
         <p:spPr>
           <a:xfrm>
-            <a:off x="7223760" y="4389120"/>
+            <a:off x="7223760" y="4108915"/>
             <a:ext cx="2468880" cy="457200"/>
           </a:xfrm>
           <a:prstGeom prst="rect">
@@ -12399,7 +12377,7 @@
         </p:nvSpPr>
         <p:spPr>
           <a:xfrm>
-            <a:off x="457200" y="4983480"/>
+            <a:off x="457200" y="4703275"/>
             <a:ext cx="9326880" cy="777240"/>
           </a:xfrm>
           <a:prstGeom prst="rect">
@@ -12446,7 +12424,7 @@
         </p:nvSpPr>
         <p:spPr>
           <a:xfrm>
-            <a:off x="457200" y="4983480"/>
+            <a:off x="457200" y="4703275"/>
             <a:ext cx="73152" cy="777240"/>
           </a:xfrm>
           <a:prstGeom prst="rect">
@@ -12491,7 +12469,7 @@
         </p:nvSpPr>
         <p:spPr>
           <a:xfrm>
-            <a:off x="640080" y="5166360"/>
+            <a:off x="640080" y="4886155"/>
             <a:ext cx="3566160" cy="457200"/>
           </a:xfrm>
           <a:prstGeom prst="rect">
@@ -12526,7 +12504,7 @@
         </p:nvSpPr>
         <p:spPr>
           <a:xfrm>
-            <a:off x="4480560" y="5166360"/>
+            <a:off x="4480560" y="4886155"/>
             <a:ext cx="2468880" cy="457200"/>
           </a:xfrm>
           <a:prstGeom prst="rect">
@@ -12561,7 +12539,7 @@
         </p:nvSpPr>
         <p:spPr>
           <a:xfrm>
-            <a:off x="7223760" y="5166360"/>
+            <a:off x="7223760" y="4886155"/>
             <a:ext cx="2468880" cy="457200"/>
           </a:xfrm>
           <a:prstGeom prst="rect">
@@ -12597,7 +12575,7 @@
         <p:spPr>
           <a:xfrm>
             <a:off x="365760" y="5623560"/>
-            <a:ext cx="11430000" cy="777240"/>
+            <a:ext cx="9493464" cy="777240"/>
           </a:xfrm>
           <a:prstGeom prst="roundRect">
             <a:avLst>
@@ -12645,8 +12623,8 @@
         </p:nvSpPr>
         <p:spPr>
           <a:xfrm>
-            <a:off x="594360" y="5874405"/>
-            <a:ext cx="10972800" cy="284693"/>
+            <a:off x="594360" y="5778225"/>
+            <a:ext cx="9098280" cy="477054"/>
           </a:xfrm>
           <a:prstGeom prst="rect">
             <a:avLst/>
@@ -12929,6 +12907,14 @@
   <p:clrMapOvr>
     <a:masterClrMapping/>
   </p:clrMapOvr>
+  <mc:AlternateContent xmlns:mc="http://schemas.openxmlformats.org/markup-compatibility/2006" xmlns:p14="http://schemas.microsoft.com/office/powerpoint/2010/main">
+    <mc:Choice Requires="p14">
+      <p:transition spd="slow" p14:dur="2000" advTm="21712"/>
+    </mc:Choice>
+    <mc:Fallback xmlns="">
+      <p:transition spd="slow" advTm="21712"/>
+    </mc:Fallback>
+  </mc:AlternateContent>
 </p:sld>
 </file>
 
@@ -13924,6 +13910,14 @@
   <p:clrMapOvr>
     <a:masterClrMapping/>
   </p:clrMapOvr>
+  <mc:AlternateContent xmlns:mc="http://schemas.openxmlformats.org/markup-compatibility/2006" xmlns:p14="http://schemas.microsoft.com/office/powerpoint/2010/main">
+    <mc:Choice Requires="p14">
+      <p:transition spd="slow" p14:dur="2000" advTm="40931"/>
+    </mc:Choice>
+    <mc:Fallback xmlns="">
+      <p:transition spd="slow" advTm="40931"/>
+    </mc:Fallback>
+  </mc:AlternateContent>
 </p:sld>
 </file>
 

</xml_diff>